<commit_message>
Add the team to STACK.md, the test plan and the title slide
</commit_message>
<xml_diff>
--- a/docs/presentation/kanban-lab.pptx
+++ b/docs/presentation/kanban-lab.pptx
@@ -121,14 +121,14 @@
   <p:extLst>
     <p:ext uri="{521415D9-36F7-43E2-AB2F-B90AF26B5E84}">
       <p14:sectionLst xmlns:p14="http://schemas.microsoft.com/office/powerpoint/2010/main">
-        <p14:section name="Введение" id="{b8c9f0a7-cdb3-7e37-b8e1-74ba04e5f149}">
+        <p14:section name="Введение" id="{5b1c5b82-5d84-800f-b2ef-fdcc00c124d8}">
           <p14:sldIdLst>
             <p14:sldId id="256"/>
             <p14:sldId id="257"/>
             <p14:sldId id="258"/>
           </p14:sldIdLst>
         </p14:section>
-        <p14:section name="Разработка" id="{74da4949-30f6-e8f2-c674-e063859e2aaa}">
+        <p14:section name="Разработка" id="{0dd9b7eb-a5c8-13dc-9c53-cd61d6730f72}">
           <p14:sldIdLst>
             <p14:sldId id="259"/>
             <p14:sldId id="260"/>
@@ -136,7 +136,7 @@
             <p14:sldId id="262"/>
           </p14:sldIdLst>
         </p14:section>
-        <p14:section name="Тестирование" id="{587fca5d-7e4b-5b94-3715-9903c5bbd27a}">
+        <p14:section name="Тестирование" id="{883f694b-1f5d-43e5-73a1-6222389fbcd2}">
           <p14:sldIdLst>
             <p14:sldId id="263"/>
             <p14:sldId id="264"/>
@@ -146,7 +146,7 @@
             <p14:sldId id="268"/>
           </p14:sldIdLst>
         </p14:section>
-        <p14:section name="Итоги" id="{4944c808-faa3-7ec4-72f9-90b95d2fd6b4}">
+        <p14:section name="Итоги" id="{3fb32182-9d4f-1299-b05a-9b592770314a}">
           <p14:sldIdLst>
             <p14:sldId id="269"/>
             <p14:sldId id="270"/>
@@ -3088,7 +3088,7 @@
                   <a:schemeClr val="bg2"/>
                 </a:solidFill>
               </a:rPr>
-              <a:t>Студент группы 360</a:t>
+              <a:t>Панов Д. С., Гостев Д. С. · группа 9ИС-360</a:t>
             </a:r>
             <a:endParaRPr lang="en-US" sz="2000" dirty="0"/>
           </a:p>

</xml_diff>